<commit_message>
this is my improved ppt file for final project
</commit_message>
<xml_diff>
--- a/FINALAICTPRROJECT.ppt.pptx
+++ b/FINALAICTPRROJECT.ppt.pptx
@@ -5389,6 +5389,42 @@
           </a:prstGeom>
         </p:spPr>
       </p:pic>
+      <p:pic>
+        <p:nvPicPr>
+          <p:cNvPr id="2" name="Picture 1">
+            <a:extLst>
+              <a:ext uri="{FF2B5EF4-FFF2-40B4-BE49-F238E27FC236}">
+                <a16:creationId xmlns:a16="http://schemas.microsoft.com/office/drawing/2014/main" id="{B660C48C-8238-4718-0870-E54BB9B86CED}"/>
+              </a:ext>
+            </a:extLst>
+          </p:cNvPr>
+          <p:cNvPicPr>
+            <a:picLocks noChangeAspect="1"/>
+          </p:cNvPicPr>
+          <p:nvPr/>
+        </p:nvPicPr>
+        <p:blipFill>
+          <a:blip r:embed="rId11">
+            <a:extLst>
+              <a:ext uri="{28A0092B-C50C-407E-A947-70E740481C1C}">
+                <a14:useLocalDpi xmlns:a14="http://schemas.microsoft.com/office/drawing/2010/main" val="0"/>
+              </a:ext>
+            </a:extLst>
+          </a:blip>
+          <a:stretch>
+            <a:fillRect/>
+          </a:stretch>
+        </p:blipFill>
+        <p:spPr>
+          <a:xfrm>
+            <a:off x="6642102" y="3604086"/>
+            <a:ext cx="3667408" cy="2685505"/>
+          </a:xfrm>
+          <a:prstGeom prst="rect">
+            <a:avLst/>
+          </a:prstGeom>
+        </p:spPr>
+      </p:pic>
     </p:spTree>
     <p:extLst>
       <p:ext uri="{BB962C8B-B14F-4D97-AF65-F5344CB8AC3E}">
@@ -6145,6 +6181,42 @@
           <a:xfrm rot="11040610">
             <a:off x="535168" y="2432113"/>
             <a:ext cx="1055797" cy="1055797"/>
+          </a:xfrm>
+          <a:prstGeom prst="rect">
+            <a:avLst/>
+          </a:prstGeom>
+        </p:spPr>
+      </p:pic>
+      <p:pic>
+        <p:nvPicPr>
+          <p:cNvPr id="17" name="Picture 16">
+            <a:extLst>
+              <a:ext uri="{FF2B5EF4-FFF2-40B4-BE49-F238E27FC236}">
+                <a16:creationId xmlns:a16="http://schemas.microsoft.com/office/drawing/2014/main" id="{329A1D86-5F7B-FD62-4668-65160E31167E}"/>
+              </a:ext>
+            </a:extLst>
+          </p:cNvPr>
+          <p:cNvPicPr>
+            <a:picLocks noChangeAspect="1"/>
+          </p:cNvPicPr>
+          <p:nvPr/>
+        </p:nvPicPr>
+        <p:blipFill>
+          <a:blip r:embed="rId12">
+            <a:extLst>
+              <a:ext uri="{28A0092B-C50C-407E-A947-70E740481C1C}">
+                <a14:useLocalDpi xmlns:a14="http://schemas.microsoft.com/office/drawing/2010/main" val="0"/>
+              </a:ext>
+            </a:extLst>
+          </a:blip>
+          <a:stretch>
+            <a:fillRect/>
+          </a:stretch>
+        </p:blipFill>
+        <p:spPr>
+          <a:xfrm>
+            <a:off x="5861030" y="3525732"/>
+            <a:ext cx="5029364" cy="3001556"/>
           </a:xfrm>
           <a:prstGeom prst="rect">
             <a:avLst/>
@@ -6945,6 +7017,36 @@
           </a:prstGeom>
         </p:spPr>
       </p:pic>
+      <p:pic>
+        <p:nvPicPr>
+          <p:cNvPr id="8" name="Picture 7">
+            <a:extLst>
+              <a:ext uri="{FF2B5EF4-FFF2-40B4-BE49-F238E27FC236}">
+                <a16:creationId xmlns:a16="http://schemas.microsoft.com/office/drawing/2014/main" id="{974B1E8C-4959-1F5D-A646-C02DDA6B842B}"/>
+              </a:ext>
+            </a:extLst>
+          </p:cNvPr>
+          <p:cNvPicPr>
+            <a:picLocks noChangeAspect="1"/>
+          </p:cNvPicPr>
+          <p:nvPr/>
+        </p:nvPicPr>
+        <p:blipFill>
+          <a:blip r:embed="rId11"/>
+          <a:stretch>
+            <a:fillRect/>
+          </a:stretch>
+        </p:blipFill>
+        <p:spPr>
+          <a:xfrm>
+            <a:off x="6553618" y="3475851"/>
+            <a:ext cx="4064209" cy="1759040"/>
+          </a:xfrm>
+          <a:prstGeom prst="rect">
+            <a:avLst/>
+          </a:prstGeom>
+        </p:spPr>
+      </p:pic>
     </p:spTree>
     <p:extLst>
       <p:ext uri="{BB962C8B-B14F-4D97-AF65-F5344CB8AC3E}">
@@ -7683,6 +7785,42 @@
           <a:xfrm rot="14808705">
             <a:off x="723606" y="3057510"/>
             <a:ext cx="1055797" cy="1055797"/>
+          </a:xfrm>
+          <a:prstGeom prst="rect">
+            <a:avLst/>
+          </a:prstGeom>
+        </p:spPr>
+      </p:pic>
+      <p:pic>
+        <p:nvPicPr>
+          <p:cNvPr id="4" name="Picture 3">
+            <a:extLst>
+              <a:ext uri="{FF2B5EF4-FFF2-40B4-BE49-F238E27FC236}">
+                <a16:creationId xmlns:a16="http://schemas.microsoft.com/office/drawing/2014/main" id="{E738D961-E528-3D7C-0EFD-0BABC8648825}"/>
+              </a:ext>
+            </a:extLst>
+          </p:cNvPr>
+          <p:cNvPicPr>
+            <a:picLocks noChangeAspect="1"/>
+          </p:cNvPicPr>
+          <p:nvPr/>
+        </p:nvPicPr>
+        <p:blipFill>
+          <a:blip r:embed="rId11">
+            <a:extLst>
+              <a:ext uri="{28A0092B-C50C-407E-A947-70E740481C1C}">
+                <a14:useLocalDpi xmlns:a14="http://schemas.microsoft.com/office/drawing/2010/main" val="0"/>
+              </a:ext>
+            </a:extLst>
+          </a:blip>
+          <a:stretch>
+            <a:fillRect/>
+          </a:stretch>
+        </p:blipFill>
+        <p:spPr>
+          <a:xfrm>
+            <a:off x="5987675" y="3325284"/>
+            <a:ext cx="3891493" cy="3362250"/>
           </a:xfrm>
           <a:prstGeom prst="rect">
             <a:avLst/>
@@ -8293,6 +8431,42 @@
           </a:prstGeom>
         </p:spPr>
       </p:pic>
+      <p:pic>
+        <p:nvPicPr>
+          <p:cNvPr id="6" name="Picture 5">
+            <a:extLst>
+              <a:ext uri="{FF2B5EF4-FFF2-40B4-BE49-F238E27FC236}">
+                <a16:creationId xmlns:a16="http://schemas.microsoft.com/office/drawing/2014/main" id="{1DFCF822-EE6C-2760-FCCD-8ED3DC47AD78}"/>
+              </a:ext>
+            </a:extLst>
+          </p:cNvPr>
+          <p:cNvPicPr>
+            <a:picLocks noChangeAspect="1"/>
+          </p:cNvPicPr>
+          <p:nvPr/>
+        </p:nvPicPr>
+        <p:blipFill>
+          <a:blip r:embed="rId11">
+            <a:extLst>
+              <a:ext uri="{28A0092B-C50C-407E-A947-70E740481C1C}">
+                <a14:useLocalDpi xmlns:a14="http://schemas.microsoft.com/office/drawing/2010/main" val="0"/>
+              </a:ext>
+            </a:extLst>
+          </a:blip>
+          <a:stretch>
+            <a:fillRect/>
+          </a:stretch>
+        </p:blipFill>
+        <p:spPr>
+          <a:xfrm>
+            <a:off x="6680792" y="3428999"/>
+            <a:ext cx="3004951" cy="3021282"/>
+          </a:xfrm>
+          <a:prstGeom prst="rect">
+            <a:avLst/>
+          </a:prstGeom>
+        </p:spPr>
+      </p:pic>
     </p:spTree>
     <p:extLst>
       <p:ext uri="{BB962C8B-B14F-4D97-AF65-F5344CB8AC3E}">
@@ -8990,6 +9164,42 @@
           <a:xfrm rot="18718640">
             <a:off x="182730" y="3365924"/>
             <a:ext cx="1055797" cy="1055797"/>
+          </a:xfrm>
+          <a:prstGeom prst="rect">
+            <a:avLst/>
+          </a:prstGeom>
+        </p:spPr>
+      </p:pic>
+      <p:pic>
+        <p:nvPicPr>
+          <p:cNvPr id="9" name="Picture 8">
+            <a:extLst>
+              <a:ext uri="{FF2B5EF4-FFF2-40B4-BE49-F238E27FC236}">
+                <a16:creationId xmlns:a16="http://schemas.microsoft.com/office/drawing/2014/main" id="{6E3C9909-EDDF-366A-1350-0349444136B2}"/>
+              </a:ext>
+            </a:extLst>
+          </p:cNvPr>
+          <p:cNvPicPr>
+            <a:picLocks noChangeAspect="1"/>
+          </p:cNvPicPr>
+          <p:nvPr/>
+        </p:nvPicPr>
+        <p:blipFill>
+          <a:blip r:embed="rId13">
+            <a:extLst>
+              <a:ext uri="{28A0092B-C50C-407E-A947-70E740481C1C}">
+                <a14:useLocalDpi xmlns:a14="http://schemas.microsoft.com/office/drawing/2010/main" val="0"/>
+              </a:ext>
+            </a:extLst>
+          </a:blip>
+          <a:stretch>
+            <a:fillRect/>
+          </a:stretch>
+        </p:blipFill>
+        <p:spPr>
+          <a:xfrm>
+            <a:off x="6555415" y="3852677"/>
+            <a:ext cx="3012313" cy="2783151"/>
           </a:xfrm>
           <a:prstGeom prst="rect">
             <a:avLst/>
@@ -9743,6 +9953,42 @@
           <a:xfrm rot="7984765">
             <a:off x="218243" y="2348338"/>
             <a:ext cx="1055797" cy="1055797"/>
+          </a:xfrm>
+          <a:prstGeom prst="rect">
+            <a:avLst/>
+          </a:prstGeom>
+        </p:spPr>
+      </p:pic>
+      <p:pic>
+        <p:nvPicPr>
+          <p:cNvPr id="4" name="Picture 3">
+            <a:extLst>
+              <a:ext uri="{FF2B5EF4-FFF2-40B4-BE49-F238E27FC236}">
+                <a16:creationId xmlns:a16="http://schemas.microsoft.com/office/drawing/2014/main" id="{E1F864F3-8083-067E-FA3B-BD197171FBAA}"/>
+              </a:ext>
+            </a:extLst>
+          </p:cNvPr>
+          <p:cNvPicPr>
+            <a:picLocks noChangeAspect="1"/>
+          </p:cNvPicPr>
+          <p:nvPr/>
+        </p:nvPicPr>
+        <p:blipFill>
+          <a:blip r:embed="rId7">
+            <a:extLst>
+              <a:ext uri="{28A0092B-C50C-407E-A947-70E740481C1C}">
+                <a14:useLocalDpi xmlns:a14="http://schemas.microsoft.com/office/drawing/2010/main" val="0"/>
+              </a:ext>
+            </a:extLst>
+          </a:blip>
+          <a:stretch>
+            <a:fillRect/>
+          </a:stretch>
+        </p:blipFill>
+        <p:spPr>
+          <a:xfrm>
+            <a:off x="7251704" y="3746170"/>
+            <a:ext cx="1830125" cy="3259365"/>
           </a:xfrm>
           <a:prstGeom prst="rect">
             <a:avLst/>
@@ -14366,7 +14612,7 @@
                 <a:latin typeface="Times New Roman" panose="02020603050405020304" pitchFamily="18" charset="0"/>
                 <a:cs typeface="Times New Roman" panose="02020603050405020304" pitchFamily="18" charset="0"/>
               </a:rPr>
-              <a:t>Demo Screenshot: Home Page</a:t>
+              <a:t>Home Page</a:t>
             </a:r>
           </a:p>
         </p:txBody>
@@ -14818,6 +15064,42 @@
           <a:xfrm rot="12480190">
             <a:off x="648093" y="2607484"/>
             <a:ext cx="1055797" cy="1055797"/>
+          </a:xfrm>
+          <a:prstGeom prst="rect">
+            <a:avLst/>
+          </a:prstGeom>
+        </p:spPr>
+      </p:pic>
+      <p:pic>
+        <p:nvPicPr>
+          <p:cNvPr id="4" name="Picture 3">
+            <a:extLst>
+              <a:ext uri="{FF2B5EF4-FFF2-40B4-BE49-F238E27FC236}">
+                <a16:creationId xmlns:a16="http://schemas.microsoft.com/office/drawing/2014/main" id="{B132F02F-62AA-F3F8-E1DB-EF75613F705A}"/>
+              </a:ext>
+            </a:extLst>
+          </p:cNvPr>
+          <p:cNvPicPr>
+            <a:picLocks noChangeAspect="1"/>
+          </p:cNvPicPr>
+          <p:nvPr/>
+        </p:nvPicPr>
+        <p:blipFill>
+          <a:blip r:embed="rId11">
+            <a:extLst>
+              <a:ext uri="{28A0092B-C50C-407E-A947-70E740481C1C}">
+                <a14:useLocalDpi xmlns:a14="http://schemas.microsoft.com/office/drawing/2010/main" val="0"/>
+              </a:ext>
+            </a:extLst>
+          </a:blip>
+          <a:stretch>
+            <a:fillRect/>
+          </a:stretch>
+        </p:blipFill>
+        <p:spPr>
+          <a:xfrm>
+            <a:off x="5547552" y="3548310"/>
+            <a:ext cx="5469411" cy="2577438"/>
           </a:xfrm>
           <a:prstGeom prst="rect">
             <a:avLst/>
@@ -15125,7 +15407,7 @@
         </p:nvSpPr>
         <p:spPr>
           <a:xfrm>
-            <a:off x="4687218" y="1216953"/>
+            <a:off x="4150537" y="1216951"/>
             <a:ext cx="7747000" cy="584775"/>
           </a:xfrm>
           <a:prstGeom prst="rect">
@@ -15139,13 +15421,13 @@
           </a:bodyPr>
           <a:lstStyle/>
           <a:p>
-            <a:pPr algn="just"/>
+            <a:pPr algn="ctr"/>
             <a:r>
               <a:rPr lang="en-US" sz="3200" b="1" dirty="0">
                 <a:latin typeface="Times New Roman" panose="02020603050405020304" pitchFamily="18" charset="0"/>
                 <a:cs typeface="Times New Roman" panose="02020603050405020304" pitchFamily="18" charset="0"/>
               </a:rPr>
-              <a:t>Demo Screenshot: Product / Brand Page</a:t>
+              <a:t>Product / Brand Page</a:t>
             </a:r>
           </a:p>
         </p:txBody>
@@ -15572,6 +15854,114 @@
           <a:xfrm rot="14468361">
             <a:off x="726677" y="2856734"/>
             <a:ext cx="1055797" cy="1055797"/>
+          </a:xfrm>
+          <a:prstGeom prst="rect">
+            <a:avLst/>
+          </a:prstGeom>
+        </p:spPr>
+      </p:pic>
+      <p:pic>
+        <p:nvPicPr>
+          <p:cNvPr id="4" name="Picture 3">
+            <a:extLst>
+              <a:ext uri="{FF2B5EF4-FFF2-40B4-BE49-F238E27FC236}">
+                <a16:creationId xmlns:a16="http://schemas.microsoft.com/office/drawing/2014/main" id="{9580C867-16F6-060D-DAF6-4014B8C2CE29}"/>
+              </a:ext>
+            </a:extLst>
+          </p:cNvPr>
+          <p:cNvPicPr>
+            <a:picLocks noChangeAspect="1"/>
+          </p:cNvPicPr>
+          <p:nvPr/>
+        </p:nvPicPr>
+        <p:blipFill>
+          <a:blip r:embed="rId11">
+            <a:extLst>
+              <a:ext uri="{28A0092B-C50C-407E-A947-70E740481C1C}">
+                <a14:useLocalDpi xmlns:a14="http://schemas.microsoft.com/office/drawing/2010/main" val="0"/>
+              </a:ext>
+            </a:extLst>
+          </a:blip>
+          <a:stretch>
+            <a:fillRect/>
+          </a:stretch>
+        </p:blipFill>
+        <p:spPr>
+          <a:xfrm>
+            <a:off x="4311401" y="3194920"/>
+            <a:ext cx="3785597" cy="1797405"/>
+          </a:xfrm>
+          <a:prstGeom prst="rect">
+            <a:avLst/>
+          </a:prstGeom>
+        </p:spPr>
+      </p:pic>
+      <p:pic>
+        <p:nvPicPr>
+          <p:cNvPr id="10" name="Picture 9">
+            <a:extLst>
+              <a:ext uri="{FF2B5EF4-FFF2-40B4-BE49-F238E27FC236}">
+                <a16:creationId xmlns:a16="http://schemas.microsoft.com/office/drawing/2014/main" id="{FD5DFA1B-1418-8CF2-991C-6787F17B4346}"/>
+              </a:ext>
+            </a:extLst>
+          </p:cNvPr>
+          <p:cNvPicPr>
+            <a:picLocks noChangeAspect="1"/>
+          </p:cNvPicPr>
+          <p:nvPr/>
+        </p:nvPicPr>
+        <p:blipFill>
+          <a:blip r:embed="rId12">
+            <a:extLst>
+              <a:ext uri="{28A0092B-C50C-407E-A947-70E740481C1C}">
+                <a14:useLocalDpi xmlns:a14="http://schemas.microsoft.com/office/drawing/2010/main" val="0"/>
+              </a:ext>
+            </a:extLst>
+          </a:blip>
+          <a:stretch>
+            <a:fillRect/>
+          </a:stretch>
+        </p:blipFill>
+        <p:spPr>
+          <a:xfrm>
+            <a:off x="6369922" y="5087484"/>
+            <a:ext cx="3454151" cy="1618392"/>
+          </a:xfrm>
+          <a:prstGeom prst="rect">
+            <a:avLst/>
+          </a:prstGeom>
+        </p:spPr>
+      </p:pic>
+      <p:pic>
+        <p:nvPicPr>
+          <p:cNvPr id="12" name="Picture 11">
+            <a:extLst>
+              <a:ext uri="{FF2B5EF4-FFF2-40B4-BE49-F238E27FC236}">
+                <a16:creationId xmlns:a16="http://schemas.microsoft.com/office/drawing/2014/main" id="{200359B3-8765-EC92-4751-E7E1FAA7F5E0}"/>
+              </a:ext>
+            </a:extLst>
+          </p:cNvPr>
+          <p:cNvPicPr>
+            <a:picLocks noChangeAspect="1"/>
+          </p:cNvPicPr>
+          <p:nvPr/>
+        </p:nvPicPr>
+        <p:blipFill>
+          <a:blip r:embed="rId13">
+            <a:extLst>
+              <a:ext uri="{28A0092B-C50C-407E-A947-70E740481C1C}">
+                <a14:useLocalDpi xmlns:a14="http://schemas.microsoft.com/office/drawing/2010/main" val="0"/>
+              </a:ext>
+            </a:extLst>
+          </a:blip>
+          <a:stretch>
+            <a:fillRect/>
+          </a:stretch>
+        </p:blipFill>
+        <p:spPr>
+          <a:xfrm>
+            <a:off x="8395651" y="3150172"/>
+            <a:ext cx="3785597" cy="1816605"/>
           </a:xfrm>
           <a:prstGeom prst="rect">
             <a:avLst/>
@@ -15899,7 +16289,7 @@
                 <a:latin typeface="Times New Roman" panose="02020603050405020304" pitchFamily="18" charset="0"/>
                 <a:cs typeface="Times New Roman" panose="02020603050405020304" pitchFamily="18" charset="0"/>
               </a:rPr>
-              <a:t>Demo Screenshot: Contact / Booking Page</a:t>
+              <a:t>Contact / Booking Page</a:t>
             </a:r>
             <a:r>
               <a:rPr lang="en-US" b="1" dirty="0">
@@ -16186,6 +16576,42 @@
           <a:xfrm rot="15781008">
             <a:off x="640212" y="3219096"/>
             <a:ext cx="1055797" cy="1055797"/>
+          </a:xfrm>
+          <a:prstGeom prst="rect">
+            <a:avLst/>
+          </a:prstGeom>
+        </p:spPr>
+      </p:pic>
+      <p:pic>
+        <p:nvPicPr>
+          <p:cNvPr id="4" name="Picture 3">
+            <a:extLst>
+              <a:ext uri="{FF2B5EF4-FFF2-40B4-BE49-F238E27FC236}">
+                <a16:creationId xmlns:a16="http://schemas.microsoft.com/office/drawing/2014/main" id="{DB4D19F1-95DB-6D2C-C343-1230E5F8DB3E}"/>
+              </a:ext>
+            </a:extLst>
+          </p:cNvPr>
+          <p:cNvPicPr>
+            <a:picLocks noChangeAspect="1"/>
+          </p:cNvPicPr>
+          <p:nvPr/>
+        </p:nvPicPr>
+        <p:blipFill>
+          <a:blip r:embed="rId11">
+            <a:extLst>
+              <a:ext uri="{28A0092B-C50C-407E-A947-70E740481C1C}">
+                <a14:useLocalDpi xmlns:a14="http://schemas.microsoft.com/office/drawing/2010/main" val="0"/>
+              </a:ext>
+            </a:extLst>
+          </a:blip>
+          <a:stretch>
+            <a:fillRect/>
+          </a:stretch>
+        </p:blipFill>
+        <p:spPr>
+          <a:xfrm>
+            <a:off x="5444418" y="3423772"/>
+            <a:ext cx="6212641" cy="2883269"/>
           </a:xfrm>
           <a:prstGeom prst="rect">
             <a:avLst/>
@@ -16493,7 +16919,7 @@
         </p:nvSpPr>
         <p:spPr>
           <a:xfrm>
-            <a:off x="3957874" y="1365855"/>
+            <a:off x="3957874" y="737205"/>
             <a:ext cx="8234126" cy="584775"/>
           </a:xfrm>
           <a:prstGeom prst="rect">
@@ -16534,7 +16960,7 @@
         </p:nvSpPr>
         <p:spPr bwMode="auto">
           <a:xfrm>
-            <a:off x="5415693" y="1853991"/>
+            <a:off x="5415693" y="1225341"/>
             <a:ext cx="4764446" cy="2246769"/>
           </a:xfrm>
           <a:prstGeom prst="rect">
@@ -17089,6 +17515,42 @@
           <a:xfrm rot="18721281">
             <a:off x="403665" y="3414210"/>
             <a:ext cx="1055797" cy="1055797"/>
+          </a:xfrm>
+          <a:prstGeom prst="rect">
+            <a:avLst/>
+          </a:prstGeom>
+        </p:spPr>
+      </p:pic>
+      <p:pic>
+        <p:nvPicPr>
+          <p:cNvPr id="4" name="Picture 3">
+            <a:extLst>
+              <a:ext uri="{FF2B5EF4-FFF2-40B4-BE49-F238E27FC236}">
+                <a16:creationId xmlns:a16="http://schemas.microsoft.com/office/drawing/2014/main" id="{264B75D3-D570-E0C4-BFB3-0C18FACF535F}"/>
+              </a:ext>
+            </a:extLst>
+          </p:cNvPr>
+          <p:cNvPicPr>
+            <a:picLocks noChangeAspect="1"/>
+          </p:cNvPicPr>
+          <p:nvPr/>
+        </p:nvPicPr>
+        <p:blipFill>
+          <a:blip r:embed="rId11">
+            <a:extLst>
+              <a:ext uri="{28A0092B-C50C-407E-A947-70E740481C1C}">
+                <a14:useLocalDpi xmlns:a14="http://schemas.microsoft.com/office/drawing/2010/main" val="0"/>
+              </a:ext>
+            </a:extLst>
+          </a:blip>
+          <a:stretch>
+            <a:fillRect/>
+          </a:stretch>
+        </p:blipFill>
+        <p:spPr>
+          <a:xfrm>
+            <a:off x="7090979" y="3586390"/>
+            <a:ext cx="2182455" cy="3183630"/>
           </a:xfrm>
           <a:prstGeom prst="rect">
             <a:avLst/>

</xml_diff>